<commit_message>
Run every scenario in all five environments by default
Cislunar space and the lunar surface join the default batch. A scenario
now runs in every environment it selects, best and worst course in each,
plus 2 runs at CLiFF odds: up to 12 runs, fewer for conditions that
occur only in some environments (4 for lunar dust exposure, which had
no default environment before). Docs, guide, form text and the overview
deck are updated.

Co-Authored-By: Claude Opus 5.5 <noreply@anthropic.com>
Claude-Session: https://claude.ai/code/session_01VF7ik2SZWw6s4XoHG6DvCz
</commit_message>
<xml_diff>
--- a/docs/presentations/MedSim-Eval-overview.pptx
+++ b/docs/presentations/MedSim-Eval-overview.pptx
@@ -115,13 +115,13 @@
   <p:extLst>
     <p:ext uri="{521415D9-36F7-43E2-AB2F-B90AF26B5E84}">
       <p14:sectionLst xmlns:p14="http://schemas.microsoft.com/office/powerpoint/2010/main">
-        <p14:section name="Introduction" id="{ef173c93-9904-54d6-4610-87ffb05a151e}">
+        <p14:section name="Introduction" id="{84972df3-f1a3-4a6e-1fb7-1cae7c540384}">
           <p14:sldIdLst>
             <p14:sldId id="256"/>
             <p14:sldId id="257"/>
           </p14:sldIdLst>
         </p14:section>
-        <p14:section name="How it works" id="{7825113a-c115-d665-a826-0fa2e0374d97}">
+        <p14:section name="How it works" id="{6b42c078-29d6-2fba-40ae-10c96331b2c2}">
           <p14:sldIdLst>
             <p14:sldId id="258"/>
             <p14:sldId id="259"/>
@@ -129,12 +129,12 @@
             <p14:sldId id="261"/>
           </p14:sldIdLst>
         </p14:section>
-        <p14:section name="Example" id="{ce7a2abb-ca29-f142-ab73-96e3c156b08c}">
+        <p14:section name="Example" id="{ad8bf46c-8b3d-433a-71e9-10eb4b42423d}">
           <p14:sldIdLst>
             <p14:sldId id="262"/>
           </p14:sldIdLst>
         </p14:section>
-        <p14:section name="Plan of work" id="{55f81797-b65a-ceb4-d21b-371db57b4199}">
+        <p14:section name="Plan of work" id="{cf838fb4-6335-f7a9-189d-70654b9d307c}">
           <p14:sldIdLst>
             <p14:sldId id="263"/>
             <p14:sldId id="264"/>
@@ -5725,7 +5725,7 @@
                   <a:schemeClr val="tx1"/>
                 </a:solidFill>
               </a:rPr>
-              <a:t>Reads all 8 runs, summarises and flags anomalies</a:t>
+              <a:t>Reads every run, summarises and flags anomalies</a:t>
             </a:r>
             <a:endParaRPr lang="en-US" sz="1400" dirty="0"/>
           </a:p>
@@ -6926,7 +6926,7 @@
                   <a:schemeClr val="tx2"/>
                 </a:solidFill>
               </a:rPr>
-              <a:t>Each scenario runs 8 times, in 3 mission settings</a:t>
+              <a:t>Each scenario runs up to 12 times, in 5 settings</a:t>
             </a:r>
             <a:endParaRPr lang="en-US" sz="3400" dirty="0"/>
           </a:p>
@@ -6940,8 +6940,8 @@
         </p:nvSpPr>
         <p:spPr>
           <a:xfrm>
-            <a:off x="548640" y="1371600"/>
-            <a:ext cx="5303520" cy="365760"/>
+            <a:off x="548640" y="1325880"/>
+            <a:ext cx="5852160" cy="365760"/>
           </a:xfrm>
           <a:prstGeom prst="rect">
             <a:avLst/>
@@ -6973,14 +6973,14 @@
       </p:sp>
       <p:sp>
         <p:nvSpPr>
-          <p:cNvPr id="4" name="Env 1"/>
+          <p:cNvPr id="4" name="Runs subheading"/>
           <p:cNvSpPr txBox="1"/>
           <p:nvPr/>
         </p:nvSpPr>
         <p:spPr>
           <a:xfrm>
-            <a:off x="1783080" y="1828800"/>
-            <a:ext cx="1280160" cy="457200"/>
+            <a:off x="548640" y="1709928"/>
+            <a:ext cx="5943600" cy="320040"/>
           </a:xfrm>
           <a:prstGeom prst="rect">
             <a:avLst/>
@@ -6989,6 +6989,42 @@
           <a:ln/>
         </p:spPr>
         <p:txBody>
+          <a:bodyPr wrap="square" lIns="0" tIns="0" rIns="0" bIns="0" rtlCol="0" anchor="t"/>
+          <a:lstStyle/>
+          <a:p>
+            <a:pPr indent="0" marL="0">
+              <a:buNone/>
+            </a:pPr>
+            <a:r>
+              <a:rPr lang="en-US" sz="1300" dirty="0">
+                <a:solidFill>
+                  <a:schemeClr val="accent3"/>
+                </a:solidFill>
+              </a:rPr>
+              <a:t>Environments where the condition can't occur are skipped.</a:t>
+            </a:r>
+            <a:endParaRPr lang="en-US" sz="1300" dirty="0"/>
+          </a:p>
+        </p:txBody>
+      </p:sp>
+      <p:sp>
+        <p:nvSpPr>
+          <p:cNvPr id="5" name="Env 1"/>
+          <p:cNvSpPr txBox="1"/>
+          <p:nvPr/>
+        </p:nvSpPr>
+        <p:spPr>
+          <a:xfrm>
+            <a:off x="1737360" y="2103120"/>
+            <a:ext cx="914400" cy="457200"/>
+          </a:xfrm>
+          <a:prstGeom prst="rect">
+            <a:avLst/>
+          </a:prstGeom>
+          <a:noFill/>
+          <a:ln/>
+        </p:spPr>
+        <p:txBody>
           <a:bodyPr wrap="square" lIns="0" tIns="0" rIns="0" bIns="0" rtlCol="0" anchor="b"/>
           <a:lstStyle/>
           <a:p>
@@ -6996,27 +7032,27 @@
               <a:buNone/>
             </a:pPr>
             <a:r>
-              <a:rPr lang="en-US" sz="1300" b="1" dirty="0">
+              <a:rPr lang="en-US" sz="1200" b="1" dirty="0">
                 <a:solidFill>
                   <a:schemeClr val="tx2"/>
                 </a:solidFill>
               </a:rPr>
               <a:t>Low Earth orbit</a:t>
             </a:r>
-            <a:endParaRPr lang="en-US" sz="1300" dirty="0"/>
-          </a:p>
-        </p:txBody>
-      </p:sp>
-      <p:sp>
-        <p:nvSpPr>
-          <p:cNvPr id="5" name="Env 2"/>
+            <a:endParaRPr lang="en-US" sz="1200" dirty="0"/>
+          </a:p>
+        </p:txBody>
+      </p:sp>
+      <p:sp>
+        <p:nvSpPr>
+          <p:cNvPr id="6" name="Env 2"/>
           <p:cNvSpPr txBox="1"/>
           <p:nvPr/>
         </p:nvSpPr>
         <p:spPr>
           <a:xfrm>
-            <a:off x="3154680" y="1828800"/>
-            <a:ext cx="1280160" cy="457200"/>
+            <a:off x="2724912" y="2103120"/>
+            <a:ext cx="914400" cy="457200"/>
           </a:xfrm>
           <a:prstGeom prst="rect">
             <a:avLst/>
@@ -7032,27 +7068,99 @@
               <a:buNone/>
             </a:pPr>
             <a:r>
-              <a:rPr lang="en-US" sz="1300" b="1" dirty="0">
+              <a:rPr lang="en-US" sz="1200" b="1" dirty="0">
                 <a:solidFill>
                   <a:schemeClr val="tx2"/>
                 </a:solidFill>
               </a:rPr>
+              <a:t>Cislunar space</a:t>
+            </a:r>
+            <a:endParaRPr lang="en-US" sz="1200" dirty="0"/>
+          </a:p>
+        </p:txBody>
+      </p:sp>
+      <p:sp>
+        <p:nvSpPr>
+          <p:cNvPr id="7" name="Env 3"/>
+          <p:cNvSpPr txBox="1"/>
+          <p:nvPr/>
+        </p:nvSpPr>
+        <p:spPr>
+          <a:xfrm>
+            <a:off x="3712464" y="2103120"/>
+            <a:ext cx="914400" cy="457200"/>
+          </a:xfrm>
+          <a:prstGeom prst="rect">
+            <a:avLst/>
+          </a:prstGeom>
+          <a:noFill/>
+          <a:ln/>
+        </p:spPr>
+        <p:txBody>
+          <a:bodyPr wrap="square" lIns="0" tIns="0" rIns="0" bIns="0" rtlCol="0" anchor="b"/>
+          <a:lstStyle/>
+          <a:p>
+            <a:pPr algn="ctr" indent="0" marL="0">
+              <a:buNone/>
+            </a:pPr>
+            <a:r>
+              <a:rPr lang="en-US" sz="1200" b="1" dirty="0">
+                <a:solidFill>
+                  <a:schemeClr val="tx2"/>
+                </a:solidFill>
+              </a:rPr>
+              <a:t>Lunar surface</a:t>
+            </a:r>
+            <a:endParaRPr lang="en-US" sz="1200" dirty="0"/>
+          </a:p>
+        </p:txBody>
+      </p:sp>
+      <p:sp>
+        <p:nvSpPr>
+          <p:cNvPr id="8" name="Env 4"/>
+          <p:cNvSpPr txBox="1"/>
+          <p:nvPr/>
+        </p:nvSpPr>
+        <p:spPr>
+          <a:xfrm>
+            <a:off x="4700016" y="2103120"/>
+            <a:ext cx="914400" cy="457200"/>
+          </a:xfrm>
+          <a:prstGeom prst="rect">
+            <a:avLst/>
+          </a:prstGeom>
+          <a:noFill/>
+          <a:ln/>
+        </p:spPr>
+        <p:txBody>
+          <a:bodyPr wrap="square" lIns="0" tIns="0" rIns="0" bIns="0" rtlCol="0" anchor="b"/>
+          <a:lstStyle/>
+          <a:p>
+            <a:pPr algn="ctr" indent="0" marL="0">
+              <a:buNone/>
+            </a:pPr>
+            <a:r>
+              <a:rPr lang="en-US" sz="1200" b="1" dirty="0">
+                <a:solidFill>
+                  <a:schemeClr val="tx2"/>
+                </a:solidFill>
+              </a:rPr>
               <a:t>Mars transit</a:t>
             </a:r>
-            <a:endParaRPr lang="en-US" sz="1300" dirty="0"/>
-          </a:p>
-        </p:txBody>
-      </p:sp>
-      <p:sp>
-        <p:nvSpPr>
-          <p:cNvPr id="6" name="Env 3"/>
+            <a:endParaRPr lang="en-US" sz="1200" dirty="0"/>
+          </a:p>
+        </p:txBody>
+      </p:sp>
+      <p:sp>
+        <p:nvSpPr>
+          <p:cNvPr id="9" name="Env 5"/>
           <p:cNvSpPr txBox="1"/>
           <p:nvPr/>
         </p:nvSpPr>
         <p:spPr>
           <a:xfrm>
-            <a:off x="4526280" y="1828800"/>
-            <a:ext cx="1280160" cy="457200"/>
+            <a:off x="5687568" y="2103120"/>
+            <a:ext cx="914400" cy="457200"/>
           </a:xfrm>
           <a:prstGeom prst="rect">
             <a:avLst/>
@@ -7068,27 +7176,27 @@
               <a:buNone/>
             </a:pPr>
             <a:r>
-              <a:rPr lang="en-US" sz="1300" b="1" dirty="0">
+              <a:rPr lang="en-US" sz="1200" b="1" dirty="0">
                 <a:solidFill>
                   <a:schemeClr val="tx2"/>
                 </a:solidFill>
               </a:rPr>
               <a:t>Mars surface</a:t>
             </a:r>
-            <a:endParaRPr lang="en-US" sz="1300" dirty="0"/>
-          </a:p>
-        </p:txBody>
-      </p:sp>
-      <p:sp>
-        <p:nvSpPr>
-          <p:cNvPr id="7" name="Course 1"/>
+            <a:endParaRPr lang="en-US" sz="1200" dirty="0"/>
+          </a:p>
+        </p:txBody>
+      </p:sp>
+      <p:sp>
+        <p:nvSpPr>
+          <p:cNvPr id="10" name="Course 1"/>
           <p:cNvSpPr txBox="1"/>
           <p:nvPr/>
         </p:nvSpPr>
         <p:spPr>
           <a:xfrm>
-            <a:off x="548640" y="2377440"/>
-            <a:ext cx="1188720" cy="777240"/>
+            <a:off x="548640" y="2651760"/>
+            <a:ext cx="1143000" cy="749808"/>
           </a:xfrm>
           <a:prstGeom prst="rect">
             <a:avLst/>
@@ -7117,18 +7225,18 @@
       </p:sp>
       <p:sp>
         <p:nvSpPr>
-          <p:cNvPr id="8" name="Run 1"/>
+          <p:cNvPr id="11" name="Run 1"/>
           <p:cNvSpPr/>
           <p:nvPr/>
         </p:nvSpPr>
         <p:spPr>
           <a:xfrm>
-            <a:off x="1783080" y="2377440"/>
-            <a:ext cx="1280160" cy="777240"/>
+            <a:off x="1737360" y="2651760"/>
+            <a:ext cx="914400" cy="749808"/>
           </a:xfrm>
           <a:prstGeom prst="roundRect">
             <a:avLst>
-              <a:gd name="adj" fmla="val 9412"/>
+              <a:gd name="adj" fmla="val 9756"/>
             </a:avLst>
           </a:prstGeom>
           <a:solidFill>
@@ -7144,31 +7252,31 @@
               <a:buNone/>
             </a:pPr>
             <a:r>
-              <a:rPr lang="en-US" sz="1500" b="1" dirty="0">
+              <a:rPr lang="en-US" sz="1400" b="1" dirty="0">
                 <a:solidFill>
                   <a:schemeClr val="bg1"/>
                 </a:solidFill>
               </a:rPr>
               <a:t>Run 1</a:t>
             </a:r>
-            <a:endParaRPr lang="en-US" sz="1500" dirty="0"/>
-          </a:p>
-        </p:txBody>
-      </p:sp>
-      <p:sp>
-        <p:nvSpPr>
-          <p:cNvPr id="9" name="Run 2"/>
+            <a:endParaRPr lang="en-US" sz="1400" dirty="0"/>
+          </a:p>
+        </p:txBody>
+      </p:sp>
+      <p:sp>
+        <p:nvSpPr>
+          <p:cNvPr id="12" name="Run 2"/>
           <p:cNvSpPr/>
           <p:nvPr/>
         </p:nvSpPr>
         <p:spPr>
           <a:xfrm>
-            <a:off x="3154680" y="2377440"/>
-            <a:ext cx="1280160" cy="777240"/>
+            <a:off x="2724912" y="2651760"/>
+            <a:ext cx="914400" cy="749808"/>
           </a:xfrm>
           <a:prstGeom prst="roundRect">
             <a:avLst>
-              <a:gd name="adj" fmla="val 9412"/>
+              <a:gd name="adj" fmla="val 9756"/>
             </a:avLst>
           </a:prstGeom>
           <a:solidFill>
@@ -7184,31 +7292,31 @@
               <a:buNone/>
             </a:pPr>
             <a:r>
-              <a:rPr lang="en-US" sz="1500" b="1" dirty="0">
+              <a:rPr lang="en-US" sz="1400" b="1" dirty="0">
                 <a:solidFill>
                   <a:schemeClr val="bg1"/>
                 </a:solidFill>
               </a:rPr>
               <a:t>Run 2</a:t>
             </a:r>
-            <a:endParaRPr lang="en-US" sz="1500" dirty="0"/>
-          </a:p>
-        </p:txBody>
-      </p:sp>
-      <p:sp>
-        <p:nvSpPr>
-          <p:cNvPr id="10" name="Run 3"/>
+            <a:endParaRPr lang="en-US" sz="1400" dirty="0"/>
+          </a:p>
+        </p:txBody>
+      </p:sp>
+      <p:sp>
+        <p:nvSpPr>
+          <p:cNvPr id="13" name="Run 3"/>
           <p:cNvSpPr/>
           <p:nvPr/>
         </p:nvSpPr>
         <p:spPr>
           <a:xfrm>
-            <a:off x="4526280" y="2377440"/>
-            <a:ext cx="1280160" cy="777240"/>
+            <a:off x="3712464" y="2651760"/>
+            <a:ext cx="914400" cy="749808"/>
           </a:xfrm>
           <a:prstGeom prst="roundRect">
             <a:avLst>
-              <a:gd name="adj" fmla="val 9412"/>
+              <a:gd name="adj" fmla="val 9756"/>
             </a:avLst>
           </a:prstGeom>
           <a:solidFill>
@@ -7224,67 +7332,147 @@
               <a:buNone/>
             </a:pPr>
             <a:r>
-              <a:rPr lang="en-US" sz="1500" b="1" dirty="0">
+              <a:rPr lang="en-US" sz="1400" b="1" dirty="0">
                 <a:solidFill>
                   <a:schemeClr val="bg1"/>
                 </a:solidFill>
               </a:rPr>
               <a:t>Run 3</a:t>
             </a:r>
-            <a:endParaRPr lang="en-US" sz="1500" dirty="0"/>
-          </a:p>
-        </p:txBody>
-      </p:sp>
-      <p:sp>
-        <p:nvSpPr>
-          <p:cNvPr id="11" name="Course 2"/>
-          <p:cNvSpPr txBox="1"/>
-          <p:nvPr/>
-        </p:nvSpPr>
-        <p:spPr>
-          <a:xfrm>
-            <a:off x="548640" y="3291840"/>
-            <a:ext cx="1188720" cy="777240"/>
-          </a:xfrm>
-          <a:prstGeom prst="rect">
-            <a:avLst/>
-          </a:prstGeom>
-          <a:noFill/>
-          <a:ln/>
-        </p:spPr>
-        <p:txBody>
-          <a:bodyPr wrap="square" lIns="0" tIns="0" rIns="0" bIns="0" rtlCol="0" anchor="ctr"/>
-          <a:lstStyle/>
-          <a:p>
-            <a:pPr indent="0" marL="0">
-              <a:buNone/>
-            </a:pPr>
-            <a:r>
-              <a:rPr lang="en-US" sz="1400" b="1" dirty="0">
-                <a:solidFill>
-                  <a:schemeClr val="tx2"/>
-                </a:solidFill>
-              </a:rPr>
-              <a:t>Worst course</a:t>
-            </a:r>
             <a:endParaRPr lang="en-US" sz="1400" dirty="0"/>
           </a:p>
         </p:txBody>
       </p:sp>
       <p:sp>
         <p:nvSpPr>
-          <p:cNvPr id="12" name="Run 4"/>
+          <p:cNvPr id="14" name="Run 4"/>
           <p:cNvSpPr/>
           <p:nvPr/>
         </p:nvSpPr>
         <p:spPr>
           <a:xfrm>
-            <a:off x="1783080" y="3291840"/>
-            <a:ext cx="1280160" cy="777240"/>
+            <a:off x="4700016" y="2651760"/>
+            <a:ext cx="914400" cy="749808"/>
           </a:xfrm>
           <a:prstGeom prst="roundRect">
             <a:avLst>
-              <a:gd name="adj" fmla="val 9412"/>
+              <a:gd name="adj" fmla="val 9756"/>
+            </a:avLst>
+          </a:prstGeom>
+          <a:solidFill>
+            <a:schemeClr val="tx2"/>
+          </a:solidFill>
+          <a:ln/>
+        </p:spPr>
+        <p:txBody>
+          <a:bodyPr wrap="square" lIns="0" tIns="0" rIns="0" bIns="0" rtlCol="0" anchor="ctr"/>
+          <a:lstStyle/>
+          <a:p>
+            <a:pPr algn="ctr" indent="0" marL="0">
+              <a:buNone/>
+            </a:pPr>
+            <a:r>
+              <a:rPr lang="en-US" sz="1400" b="1" dirty="0">
+                <a:solidFill>
+                  <a:schemeClr val="bg1"/>
+                </a:solidFill>
+              </a:rPr>
+              <a:t>Run 4</a:t>
+            </a:r>
+            <a:endParaRPr lang="en-US" sz="1400" dirty="0"/>
+          </a:p>
+        </p:txBody>
+      </p:sp>
+      <p:sp>
+        <p:nvSpPr>
+          <p:cNvPr id="15" name="Run 5"/>
+          <p:cNvSpPr/>
+          <p:nvPr/>
+        </p:nvSpPr>
+        <p:spPr>
+          <a:xfrm>
+            <a:off x="5687568" y="2651760"/>
+            <a:ext cx="914400" cy="749808"/>
+          </a:xfrm>
+          <a:prstGeom prst="roundRect">
+            <a:avLst>
+              <a:gd name="adj" fmla="val 9756"/>
+            </a:avLst>
+          </a:prstGeom>
+          <a:solidFill>
+            <a:schemeClr val="tx2"/>
+          </a:solidFill>
+          <a:ln/>
+        </p:spPr>
+        <p:txBody>
+          <a:bodyPr wrap="square" lIns="0" tIns="0" rIns="0" bIns="0" rtlCol="0" anchor="ctr"/>
+          <a:lstStyle/>
+          <a:p>
+            <a:pPr algn="ctr" indent="0" marL="0">
+              <a:buNone/>
+            </a:pPr>
+            <a:r>
+              <a:rPr lang="en-US" sz="1400" b="1" dirty="0">
+                <a:solidFill>
+                  <a:schemeClr val="bg1"/>
+                </a:solidFill>
+              </a:rPr>
+              <a:t>Run 5</a:t>
+            </a:r>
+            <a:endParaRPr lang="en-US" sz="1400" dirty="0"/>
+          </a:p>
+        </p:txBody>
+      </p:sp>
+      <p:sp>
+        <p:nvSpPr>
+          <p:cNvPr id="16" name="Course 2"/>
+          <p:cNvSpPr txBox="1"/>
+          <p:nvPr/>
+        </p:nvSpPr>
+        <p:spPr>
+          <a:xfrm>
+            <a:off x="548640" y="3520440"/>
+            <a:ext cx="1143000" cy="749808"/>
+          </a:xfrm>
+          <a:prstGeom prst="rect">
+            <a:avLst/>
+          </a:prstGeom>
+          <a:noFill/>
+          <a:ln/>
+        </p:spPr>
+        <p:txBody>
+          <a:bodyPr wrap="square" lIns="0" tIns="0" rIns="0" bIns="0" rtlCol="0" anchor="ctr"/>
+          <a:lstStyle/>
+          <a:p>
+            <a:pPr indent="0" marL="0">
+              <a:buNone/>
+            </a:pPr>
+            <a:r>
+              <a:rPr lang="en-US" sz="1400" b="1" dirty="0">
+                <a:solidFill>
+                  <a:schemeClr val="tx2"/>
+                </a:solidFill>
+              </a:rPr>
+              <a:t>Worst course</a:t>
+            </a:r>
+            <a:endParaRPr lang="en-US" sz="1400" dirty="0"/>
+          </a:p>
+        </p:txBody>
+      </p:sp>
+      <p:sp>
+        <p:nvSpPr>
+          <p:cNvPr id="17" name="Run 6"/>
+          <p:cNvSpPr/>
+          <p:nvPr/>
+        </p:nvSpPr>
+        <p:spPr>
+          <a:xfrm>
+            <a:off x="1737360" y="3520440"/>
+            <a:ext cx="914400" cy="749808"/>
+          </a:xfrm>
+          <a:prstGeom prst="roundRect">
+            <a:avLst>
+              <a:gd name="adj" fmla="val 9756"/>
             </a:avLst>
           </a:prstGeom>
           <a:solidFill>
@@ -7300,31 +7488,31 @@
               <a:buNone/>
             </a:pPr>
             <a:r>
-              <a:rPr lang="en-US" sz="1500" b="1" dirty="0">
+              <a:rPr lang="en-US" sz="1400" b="1" dirty="0">
                 <a:solidFill>
                   <a:schemeClr val="bg1"/>
                 </a:solidFill>
               </a:rPr>
-              <a:t>Run 4</a:t>
-            </a:r>
-            <a:endParaRPr lang="en-US" sz="1500" dirty="0"/>
-          </a:p>
-        </p:txBody>
-      </p:sp>
-      <p:sp>
-        <p:nvSpPr>
-          <p:cNvPr id="13" name="Run 5"/>
+              <a:t>Run 6</a:t>
+            </a:r>
+            <a:endParaRPr lang="en-US" sz="1400" dirty="0"/>
+          </a:p>
+        </p:txBody>
+      </p:sp>
+      <p:sp>
+        <p:nvSpPr>
+          <p:cNvPr id="18" name="Run 7"/>
           <p:cNvSpPr/>
           <p:nvPr/>
         </p:nvSpPr>
         <p:spPr>
           <a:xfrm>
-            <a:off x="3154680" y="3291840"/>
-            <a:ext cx="1280160" cy="777240"/>
+            <a:off x="2724912" y="3520440"/>
+            <a:ext cx="914400" cy="749808"/>
           </a:xfrm>
           <a:prstGeom prst="roundRect">
             <a:avLst>
-              <a:gd name="adj" fmla="val 9412"/>
+              <a:gd name="adj" fmla="val 9756"/>
             </a:avLst>
           </a:prstGeom>
           <a:solidFill>
@@ -7340,31 +7528,31 @@
               <a:buNone/>
             </a:pPr>
             <a:r>
-              <a:rPr lang="en-US" sz="1500" b="1" dirty="0">
+              <a:rPr lang="en-US" sz="1400" b="1" dirty="0">
                 <a:solidFill>
                   <a:schemeClr val="bg1"/>
                 </a:solidFill>
               </a:rPr>
-              <a:t>Run 5</a:t>
-            </a:r>
-            <a:endParaRPr lang="en-US" sz="1500" dirty="0"/>
-          </a:p>
-        </p:txBody>
-      </p:sp>
-      <p:sp>
-        <p:nvSpPr>
-          <p:cNvPr id="14" name="Run 6"/>
+              <a:t>Run 7</a:t>
+            </a:r>
+            <a:endParaRPr lang="en-US" sz="1400" dirty="0"/>
+          </a:p>
+        </p:txBody>
+      </p:sp>
+      <p:sp>
+        <p:nvSpPr>
+          <p:cNvPr id="19" name="Run 8"/>
           <p:cNvSpPr/>
           <p:nvPr/>
         </p:nvSpPr>
         <p:spPr>
           <a:xfrm>
-            <a:off x="4526280" y="3291840"/>
-            <a:ext cx="1280160" cy="777240"/>
+            <a:off x="3712464" y="3520440"/>
+            <a:ext cx="914400" cy="749808"/>
           </a:xfrm>
           <a:prstGeom prst="roundRect">
             <a:avLst>
-              <a:gd name="adj" fmla="val 9412"/>
+              <a:gd name="adj" fmla="val 9756"/>
             </a:avLst>
           </a:prstGeom>
           <a:solidFill>
@@ -7380,48 +7568,12 @@
               <a:buNone/>
             </a:pPr>
             <a:r>
-              <a:rPr lang="en-US" sz="1500" b="1" dirty="0">
+              <a:rPr lang="en-US" sz="1400" b="1" dirty="0">
                 <a:solidFill>
                   <a:schemeClr val="bg1"/>
                 </a:solidFill>
               </a:rPr>
-              <a:t>Run 6</a:t>
-            </a:r>
-            <a:endParaRPr lang="en-US" sz="1500" dirty="0"/>
-          </a:p>
-        </p:txBody>
-      </p:sp>
-      <p:sp>
-        <p:nvSpPr>
-          <p:cNvPr id="15" name="Course 3"/>
-          <p:cNvSpPr txBox="1"/>
-          <p:nvPr/>
-        </p:nvSpPr>
-        <p:spPr>
-          <a:xfrm>
-            <a:off x="548640" y="4206240"/>
-            <a:ext cx="1188720" cy="777240"/>
-          </a:xfrm>
-          <a:prstGeom prst="rect">
-            <a:avLst/>
-          </a:prstGeom>
-          <a:noFill/>
-          <a:ln/>
-        </p:spPr>
-        <p:txBody>
-          <a:bodyPr wrap="square" lIns="0" tIns="0" rIns="0" bIns="0" rtlCol="0" anchor="ctr"/>
-          <a:lstStyle/>
-          <a:p>
-            <a:pPr indent="0" marL="0">
-              <a:buNone/>
-            </a:pPr>
-            <a:r>
-              <a:rPr lang="en-US" sz="1400" b="1" dirty="0">
-                <a:solidFill>
-                  <a:schemeClr val="tx2"/>
-                </a:solidFill>
-              </a:rPr>
-              <a:t>CLiFF odds</a:t>
+              <a:t>Run 8</a:t>
             </a:r>
             <a:endParaRPr lang="en-US" sz="1400" dirty="0"/>
           </a:p>
@@ -7429,18 +7581,134 @@
       </p:sp>
       <p:sp>
         <p:nvSpPr>
-          <p:cNvPr id="16" name="Run 7"/>
+          <p:cNvPr id="20" name="Run 9"/>
           <p:cNvSpPr/>
           <p:nvPr/>
         </p:nvSpPr>
         <p:spPr>
           <a:xfrm>
-            <a:off x="1783080" y="4206240"/>
-            <a:ext cx="1965960" cy="777240"/>
+            <a:off x="4700016" y="3520440"/>
+            <a:ext cx="914400" cy="749808"/>
           </a:xfrm>
           <a:prstGeom prst="roundRect">
             <a:avLst>
-              <a:gd name="adj" fmla="val 9412"/>
+              <a:gd name="adj" fmla="val 9756"/>
+            </a:avLst>
+          </a:prstGeom>
+          <a:solidFill>
+            <a:schemeClr val="accent1"/>
+          </a:solidFill>
+          <a:ln/>
+        </p:spPr>
+        <p:txBody>
+          <a:bodyPr wrap="square" lIns="0" tIns="0" rIns="0" bIns="0" rtlCol="0" anchor="ctr"/>
+          <a:lstStyle/>
+          <a:p>
+            <a:pPr algn="ctr" indent="0" marL="0">
+              <a:buNone/>
+            </a:pPr>
+            <a:r>
+              <a:rPr lang="en-US" sz="1400" b="1" dirty="0">
+                <a:solidFill>
+                  <a:schemeClr val="bg1"/>
+                </a:solidFill>
+              </a:rPr>
+              <a:t>Run 9</a:t>
+            </a:r>
+            <a:endParaRPr lang="en-US" sz="1400" dirty="0"/>
+          </a:p>
+        </p:txBody>
+      </p:sp>
+      <p:sp>
+        <p:nvSpPr>
+          <p:cNvPr id="21" name="Run 10"/>
+          <p:cNvSpPr/>
+          <p:nvPr/>
+        </p:nvSpPr>
+        <p:spPr>
+          <a:xfrm>
+            <a:off x="5687568" y="3520440"/>
+            <a:ext cx="914400" cy="749808"/>
+          </a:xfrm>
+          <a:prstGeom prst="roundRect">
+            <a:avLst>
+              <a:gd name="adj" fmla="val 9756"/>
+            </a:avLst>
+          </a:prstGeom>
+          <a:solidFill>
+            <a:schemeClr val="accent1"/>
+          </a:solidFill>
+          <a:ln/>
+        </p:spPr>
+        <p:txBody>
+          <a:bodyPr wrap="square" lIns="0" tIns="0" rIns="0" bIns="0" rtlCol="0" anchor="ctr"/>
+          <a:lstStyle/>
+          <a:p>
+            <a:pPr algn="ctr" indent="0" marL="0">
+              <a:buNone/>
+            </a:pPr>
+            <a:r>
+              <a:rPr lang="en-US" sz="1400" b="1" dirty="0">
+                <a:solidFill>
+                  <a:schemeClr val="bg1"/>
+                </a:solidFill>
+              </a:rPr>
+              <a:t>Run 10</a:t>
+            </a:r>
+            <a:endParaRPr lang="en-US" sz="1400" dirty="0"/>
+          </a:p>
+        </p:txBody>
+      </p:sp>
+      <p:sp>
+        <p:nvSpPr>
+          <p:cNvPr id="22" name="Course 3"/>
+          <p:cNvSpPr txBox="1"/>
+          <p:nvPr/>
+        </p:nvSpPr>
+        <p:spPr>
+          <a:xfrm>
+            <a:off x="548640" y="4389120"/>
+            <a:ext cx="1143000" cy="749808"/>
+          </a:xfrm>
+          <a:prstGeom prst="rect">
+            <a:avLst/>
+          </a:prstGeom>
+          <a:noFill/>
+          <a:ln/>
+        </p:spPr>
+        <p:txBody>
+          <a:bodyPr wrap="square" lIns="0" tIns="0" rIns="0" bIns="0" rtlCol="0" anchor="ctr"/>
+          <a:lstStyle/>
+          <a:p>
+            <a:pPr indent="0" marL="0">
+              <a:buNone/>
+            </a:pPr>
+            <a:r>
+              <a:rPr lang="en-US" sz="1400" b="1" dirty="0">
+                <a:solidFill>
+                  <a:schemeClr val="tx2"/>
+                </a:solidFill>
+              </a:rPr>
+              <a:t>CLiFF odds</a:t>
+            </a:r>
+            <a:endParaRPr lang="en-US" sz="1400" dirty="0"/>
+          </a:p>
+        </p:txBody>
+      </p:sp>
+      <p:sp>
+        <p:nvSpPr>
+          <p:cNvPr id="23" name="Run 11"/>
+          <p:cNvSpPr/>
+          <p:nvPr/>
+        </p:nvSpPr>
+        <p:spPr>
+          <a:xfrm>
+            <a:off x="1737360" y="4389120"/>
+            <a:ext cx="2395728" cy="749808"/>
+          </a:xfrm>
+          <a:prstGeom prst="roundRect">
+            <a:avLst>
+              <a:gd name="adj" fmla="val 9756"/>
             </a:avLst>
           </a:prstGeom>
           <a:solidFill>
@@ -7456,31 +7724,31 @@
               <a:buNone/>
             </a:pPr>
             <a:r>
-              <a:rPr lang="en-US" sz="1500" b="1" dirty="0">
+              <a:rPr lang="en-US" sz="1400" b="1" dirty="0">
                 <a:solidFill>
                   <a:schemeClr val="tx2"/>
                 </a:solidFill>
               </a:rPr>
-              <a:t>Run 7</a:t>
-            </a:r>
-            <a:endParaRPr lang="en-US" sz="1500" dirty="0"/>
-          </a:p>
-        </p:txBody>
-      </p:sp>
-      <p:sp>
-        <p:nvSpPr>
-          <p:cNvPr id="17" name="Run 8"/>
+              <a:t>Run 11</a:t>
+            </a:r>
+            <a:endParaRPr lang="en-US" sz="1400" dirty="0"/>
+          </a:p>
+        </p:txBody>
+      </p:sp>
+      <p:sp>
+        <p:nvSpPr>
+          <p:cNvPr id="24" name="Run 12"/>
           <p:cNvSpPr/>
           <p:nvPr/>
         </p:nvSpPr>
         <p:spPr>
           <a:xfrm>
-            <a:off x="3840480" y="4206240"/>
-            <a:ext cx="1965960" cy="777240"/>
+            <a:off x="4206240" y="4389120"/>
+            <a:ext cx="2395728" cy="749808"/>
           </a:xfrm>
           <a:prstGeom prst="roundRect">
             <a:avLst>
-              <a:gd name="adj" fmla="val 9412"/>
+              <a:gd name="adj" fmla="val 9756"/>
             </a:avLst>
           </a:prstGeom>
           <a:solidFill>
@@ -7496,26 +7764,26 @@
               <a:buNone/>
             </a:pPr>
             <a:r>
-              <a:rPr lang="en-US" sz="1500" b="1" dirty="0">
+              <a:rPr lang="en-US" sz="1400" b="1" dirty="0">
                 <a:solidFill>
                   <a:schemeClr val="tx2"/>
                 </a:solidFill>
               </a:rPr>
-              <a:t>Run 8</a:t>
-            </a:r>
-            <a:endParaRPr lang="en-US" sz="1500" dirty="0"/>
-          </a:p>
-        </p:txBody>
-      </p:sp>
-      <p:sp>
-        <p:nvSpPr>
-          <p:cNvPr id="18" name="Clock circle"/>
+              <a:t>Run 12</a:t>
+            </a:r>
+            <a:endParaRPr lang="en-US" sz="1400" dirty="0"/>
+          </a:p>
+        </p:txBody>
+      </p:sp>
+      <p:sp>
+        <p:nvSpPr>
+          <p:cNvPr id="25" name="Clock circle"/>
           <p:cNvSpPr/>
           <p:nvPr/>
         </p:nvSpPr>
         <p:spPr>
           <a:xfrm>
-            <a:off x="548640" y="5349240"/>
+            <a:off x="548640" y="5440680"/>
             <a:ext cx="640080" cy="640080"/>
           </a:xfrm>
           <a:prstGeom prst="ellipse">
@@ -7529,7 +7797,7 @@
       </p:sp>
       <p:pic>
         <p:nvPicPr>
-          <p:cNvPr id="19" name="Clock icon" descr="preencoded.png">    </p:cNvPr>
+          <p:cNvPr id="26" name="Clock icon" descr="preencoded.png">    </p:cNvPr>
           <p:cNvPicPr>
             <a:picLocks noChangeAspect="1"/>
           </p:cNvPicPr>
@@ -7543,7 +7811,7 @@
         </p:blipFill>
         <p:spPr>
           <a:xfrm>
-            <a:off x="721462" y="5522062"/>
+            <a:off x="721462" y="5613502"/>
             <a:ext cx="294437" cy="294437"/>
           </a:xfrm>
           <a:prstGeom prst="rect">
@@ -7553,14 +7821,14 @@
       </p:pic>
       <p:sp>
         <p:nvSpPr>
-          <p:cNvPr id="20" name="Clock note"/>
+          <p:cNvPr id="27" name="Clock note"/>
           <p:cNvSpPr txBox="1"/>
           <p:nvPr/>
         </p:nvSpPr>
         <p:spPr>
           <a:xfrm>
-            <a:off x="1371600" y="5257800"/>
-            <a:ext cx="4480560" cy="868680"/>
+            <a:off x="1371600" y="5349240"/>
+            <a:ext cx="5120640" cy="822960"/>
           </a:xfrm>
           <a:prstGeom prst="rect">
             <a:avLst/>
@@ -7581,7 +7849,7 @@
                   <a:schemeClr val="tx1"/>
                 </a:solidFill>
               </a:rPr>
-              <a:t>The clock jumps ahead when nothing is happening, so a 10-day antibiotic course runs in seconds. Every run has a seed and can be replayed exactly.</a:t>
+              <a:t>The clock jumps ahead when nothing is happening, so a 10-day antibiotic course runs in seconds. Every run can be replayed exactly.</a:t>
             </a:r>
             <a:endParaRPr lang="en-US" sz="1400" dirty="0"/>
           </a:p>
@@ -7589,13 +7857,13 @@
       </p:sp>
       <p:graphicFrame>
         <p:nvGraphicFramePr>
-          <p:cNvPr id="21" name="Chart kit by vehicle" descr=""/>
+          <p:cNvPr id="28" name="Chart kit by vehicle" descr=""/>
           <p:cNvGraphicFramePr/>
           <p:nvPr/>
         </p:nvGraphicFramePr>
         <p:xfrm>
-          <a:off x="6309360" y="1325880"/>
-          <a:ext cx="5303520" cy="3931920"/>
+          <a:off x="6903720" y="1325880"/>
+          <a:ext cx="4709160" cy="3931920"/>
         </p:xfrm>
         <a:graphic xmlns:a="http://schemas.openxmlformats.org/drawingml/2006/main">
           <a:graphicData uri="http://schemas.openxmlformats.org/drawingml/2006/chart">
@@ -7605,14 +7873,14 @@
       </p:graphicFrame>
       <p:sp>
         <p:nvSpPr>
-          <p:cNvPr id="22" name="Kit note"/>
+          <p:cNvPr id="29" name="Kit note"/>
           <p:cNvSpPr txBox="1"/>
           <p:nvPr/>
         </p:nvSpPr>
         <p:spPr>
           <a:xfrm>
-            <a:off x="6309360" y="5394960"/>
-            <a:ext cx="5303520" cy="685800"/>
+            <a:off x="6903720" y="5394960"/>
+            <a:ext cx="4709160" cy="731520"/>
           </a:xfrm>
           <a:prstGeom prst="rect">
             <a:avLst/>
@@ -7633,7 +7901,7 @@
                   <a:schemeClr val="tx1"/>
                 </a:solidFill>
               </a:rPr>
-              <a:t>A checklist item that needs ultrasound is scored not applicable where none is aboard, rather than failed.</a:t>
+              <a:t>The lunar surface has the smallest kit. An item that needs equipment not aboard is scored not applicable, not failed.</a:t>
             </a:r>
             <a:endParaRPr lang="en-US" sz="1400" dirty="0"/>
           </a:p>
@@ -9104,7 +9372,7 @@
                   <a:schemeClr val="tx1"/>
                 </a:solidFill>
               </a:rPr>
-              <a:t>Scored on 19 checklist items plus the standard items, in all 8 runs. Values from the appendicitis CLiFF; pending physiologist review.</a:t>
+              <a:t>Scored on 19 checklist items plus the standard items, in every run. Values from the appendicitis CLiFF; pending physiologist review.</a:t>
             </a:r>
             <a:endParaRPr lang="en-US" sz="1400" dirty="0"/>
           </a:p>
@@ -9884,7 +10152,7 @@
                           <a:ea typeface="+mn-lt" pitchFamily="34" charset="-122"/>
                           <a:cs typeface="+mn-lt" pitchFamily="34" charset="-120"/>
                         </a:rPr>
-                        <a:t>Adapter for any assistant; MCP tools; AI crewmember; 8-run batches on a simple twin</a:t>
+                        <a:t>Adapter for any assistant; MCP tools; AI crewmember; up to 12 runs per scenario on a simple twin</a:t>
                       </a:r>
                       <a:endParaRPr lang="en-US" sz="1300" dirty="0">
                         <a:latin typeface="+mn-lt" charset="0"/>

</xml_diff>